<commit_message>
Screenshots are added. Lab 3 on progress
</commit_message>
<xml_diff>
--- a/common/CPSC357_Lectures.pptx
+++ b/common/CPSC357_Lectures.pptx
@@ -3678,17 +3678,8 @@
           <a:p>
             <a:r>
               <a:rPr lang="en-US" dirty="0"/>
-              <a:t>Splash Screen &amp; </a:t>
-            </a:r>
-            <a:r>
-              <a:rPr lang="en-US"/>
-              <a:t>Activity Indicato</a:t>
-            </a:r>
-            <a:r>
-              <a:rPr lang="en-US" dirty="0"/>
-              <a:t>r</a:t>
-            </a:r>
-            <a:endParaRPr lang="en-US"/>
+              <a:t>Splash Screen &amp; Activity Indicator</a:t>
+            </a:r>
           </a:p>
         </p:txBody>
       </p:sp>

</xml_diff>